<commit_message>
Añadir crédito del docente y pestaña de Recursos
Todas las diapositivas de título y el pie de página ahora indican
"Profe Miranda" como docente. El visor web suma una pestaña Recursos
con enlace al repositorio y descarga directa de los 32 .pptx.
</commit_message>
<xml_diff>
--- a/pptx/direccion-actores/Sesion_01_Cero_Artificio.pptx
+++ b/pptx/direccion-actores/Sesion_01_Cero_Artificio.pptx
@@ -1990,6 +1990,45 @@
         </p:nvSpPr>
         <p:spPr>
           <a:xfrm>
+            <a:off x="640080" y="960120"/>
+            <a:ext cx="10911535" cy="320040"/>
+          </a:xfrm>
+          <a:prstGeom prst="rect">
+            <a:avLst/>
+          </a:prstGeom>
+          <a:noFill/>
+          <a:ln/>
+        </p:spPr>
+        <p:txBody>
+          <a:bodyPr wrap="square" lIns="0" tIns="0" rIns="0" bIns="0" rtlCol="0" anchor="ctr"/>
+          <a:lstStyle/>
+          <a:p>
+            <a:pPr indent="0" marL="0">
+              <a:buNone/>
+            </a:pPr>
+            <a:r>
+              <a:rPr lang="en-US" sz="1100" b="1" spc="150" kern="0" dirty="0">
+                <a:solidFill>
+                  <a:srgbClr val="C9B8BE"/>
+                </a:solidFill>
+                <a:latin typeface="Calibri" pitchFamily="34" charset="0"/>
+                <a:ea typeface="Calibri" pitchFamily="34" charset="-122"/>
+                <a:cs typeface="Calibri" pitchFamily="34" charset="-120"/>
+              </a:rPr>
+              <a:t>DOCENTE · PROFE MIRANDA</a:t>
+            </a:r>
+            <a:endParaRPr lang="en-US" sz="1100" dirty="0"/>
+          </a:p>
+        </p:txBody>
+      </p:sp>
+      <p:sp>
+        <p:nvSpPr>
+          <p:cNvPr id="4" name="Text 2"/>
+          <p:cNvSpPr/>
+          <p:nvPr/>
+        </p:nvSpPr>
+        <p:spPr>
+          <a:xfrm>
             <a:off x="594360" y="1874520"/>
             <a:ext cx="7315200" cy="1005840"/>
           </a:xfrm>
@@ -2023,7 +2062,7 @@
       </p:sp>
       <p:sp>
         <p:nvSpPr>
-          <p:cNvPr id="4" name="Text 2"/>
+          <p:cNvPr id="5" name="Text 3"/>
           <p:cNvSpPr/>
           <p:nvPr/>
         </p:nvSpPr>
@@ -2062,7 +2101,7 @@
       </p:sp>
       <p:sp>
         <p:nvSpPr>
-          <p:cNvPr id="5" name="Text 3"/>
+          <p:cNvPr id="6" name="Text 4"/>
           <p:cNvSpPr/>
           <p:nvPr/>
         </p:nvSpPr>
@@ -2104,7 +2143,7 @@
       </p:sp>
       <p:sp>
         <p:nvSpPr>
-          <p:cNvPr id="6" name="Text 4"/>
+          <p:cNvPr id="7" name="Text 5"/>
           <p:cNvSpPr/>
           <p:nvPr/>
         </p:nvSpPr>
@@ -2143,7 +2182,7 @@
       </p:sp>
       <p:sp>
         <p:nvSpPr>
-          <p:cNvPr id="7" name="Text 5"/>
+          <p:cNvPr id="8" name="Text 6"/>
           <p:cNvSpPr/>
           <p:nvPr/>
         </p:nvSpPr>
@@ -2174,7 +2213,7 @@
                 <a:ea typeface="Calibri" pitchFamily="34" charset="-122"/>
                 <a:cs typeface="Calibri" pitchFamily="34" charset="-120"/>
               </a:rPr>
-              <a:t>DIRECCIÓN DE ACTORES  ·  SESIÓN 01  ·  CERO ARTIFICIO</a:t>
+              <a:t>DIRECCIÓN DE ACTORES  ·  PROFE MIRANDA  ·  SESIÓN 01  ·  CERO ARTIFICIO</a:t>
             </a:r>
             <a:endParaRPr lang="en-US" sz="900" dirty="0"/>
           </a:p>
@@ -2182,7 +2221,7 @@
       </p:sp>
       <p:sp>
         <p:nvSpPr>
-          <p:cNvPr id="8" name="Text 6"/>
+          <p:cNvPr id="9" name="Text 7"/>
           <p:cNvSpPr/>
           <p:nvPr/>
         </p:nvSpPr>
@@ -2531,7 +2570,7 @@
                 <a:ea typeface="Calibri" pitchFamily="34" charset="-122"/>
                 <a:cs typeface="Calibri" pitchFamily="34" charset="-120"/>
               </a:rPr>
-              <a:t>DIRECCIÓN DE ACTORES  ·  SESIÓN 01  ·  CERO ARTIFICIO</a:t>
+              <a:t>DIRECCIÓN DE ACTORES  ·  PROFE MIRANDA  ·  SESIÓN 01  ·  CERO ARTIFICIO</a:t>
             </a:r>
             <a:endParaRPr lang="en-US" sz="900" dirty="0"/>
           </a:p>
@@ -2869,7 +2908,7 @@
                 <a:ea typeface="Calibri" pitchFamily="34" charset="-122"/>
                 <a:cs typeface="Calibri" pitchFamily="34" charset="-120"/>
               </a:rPr>
-              <a:t>DIRECCIÓN DE ACTORES  ·  SESIÓN 01  ·  CERO ARTIFICIO</a:t>
+              <a:t>DIRECCIÓN DE ACTORES  ·  PROFE MIRANDA  ·  SESIÓN 01  ·  CERO ARTIFICIO</a:t>
             </a:r>
             <a:endParaRPr lang="en-US" sz="900" dirty="0"/>
           </a:p>
@@ -3274,7 +3313,7 @@
                 <a:ea typeface="Calibri" pitchFamily="34" charset="-122"/>
                 <a:cs typeface="Calibri" pitchFamily="34" charset="-120"/>
               </a:rPr>
-              <a:t>DIRECCIÓN DE ACTORES  ·  SESIÓN 01  ·  CERO ARTIFICIO</a:t>
+              <a:t>DIRECCIÓN DE ACTORES  ·  PROFE MIRANDA  ·  SESIÓN 01  ·  CERO ARTIFICIO</a:t>
             </a:r>
             <a:endParaRPr lang="en-US" sz="900" dirty="0"/>
           </a:p>
@@ -3524,7 +3563,7 @@
                 <a:ea typeface="Calibri" pitchFamily="34" charset="-122"/>
                 <a:cs typeface="Calibri" pitchFamily="34" charset="-120"/>
               </a:rPr>
-              <a:t>DIRECCIÓN DE ACTORES  ·  SESIÓN 01  ·  CERO ARTIFICIO</a:t>
+              <a:t>DIRECCIÓN DE ACTORES  ·  PROFE MIRANDA  ·  SESIÓN 01  ·  CERO ARTIFICIO</a:t>
             </a:r>
             <a:endParaRPr lang="en-US" sz="900" dirty="0"/>
           </a:p>
@@ -4336,7 +4375,7 @@
                 <a:ea typeface="Calibri" pitchFamily="34" charset="-122"/>
                 <a:cs typeface="Calibri" pitchFamily="34" charset="-120"/>
               </a:rPr>
-              <a:t>DIRECCIÓN DE ACTORES  ·  SESIÓN 01  ·  CERO ARTIFICIO</a:t>
+              <a:t>DIRECCIÓN DE ACTORES  ·  PROFE MIRANDA  ·  SESIÓN 01  ·  CERO ARTIFICIO</a:t>
             </a:r>
             <a:endParaRPr lang="en-US" sz="900" dirty="0"/>
           </a:p>
@@ -4628,7 +4667,7 @@
                 <a:ea typeface="Calibri" pitchFamily="34" charset="-122"/>
                 <a:cs typeface="Calibri" pitchFamily="34" charset="-120"/>
               </a:rPr>
-              <a:t>DIRECCIÓN DE ACTORES  ·  SESIÓN 01  ·  CERO ARTIFICIO</a:t>
+              <a:t>DIRECCIÓN DE ACTORES  ·  PROFE MIRANDA  ·  SESIÓN 01  ·  CERO ARTIFICIO</a:t>
             </a:r>
             <a:endParaRPr lang="en-US" sz="900" dirty="0"/>
           </a:p>
@@ -5259,7 +5298,7 @@
                 <a:ea typeface="Calibri" pitchFamily="34" charset="-122"/>
                 <a:cs typeface="Calibri" pitchFamily="34" charset="-120"/>
               </a:rPr>
-              <a:t>DIRECCIÓN DE ACTORES  ·  SESIÓN 01  ·  CERO ARTIFICIO</a:t>
+              <a:t>DIRECCIÓN DE ACTORES  ·  PROFE MIRANDA  ·  SESIÓN 01  ·  CERO ARTIFICIO</a:t>
             </a:r>
             <a:endParaRPr lang="en-US" sz="900" dirty="0"/>
           </a:p>
@@ -6062,7 +6101,7 @@
                 <a:ea typeface="Calibri" pitchFamily="34" charset="-122"/>
                 <a:cs typeface="Calibri" pitchFamily="34" charset="-120"/>
               </a:rPr>
-              <a:t>DIRECCIÓN DE ACTORES  ·  SESIÓN 01  ·  CERO ARTIFICIO</a:t>
+              <a:t>DIRECCIÓN DE ACTORES  ·  PROFE MIRANDA  ·  SESIÓN 01  ·  CERO ARTIFICIO</a:t>
             </a:r>
             <a:endParaRPr lang="en-US" sz="900" dirty="0"/>
           </a:p>
@@ -6654,7 +6693,7 @@
                 <a:ea typeface="Calibri" pitchFamily="34" charset="-122"/>
                 <a:cs typeface="Calibri" pitchFamily="34" charset="-120"/>
               </a:rPr>
-              <a:t>DIRECCIÓN DE ACTORES  ·  SESIÓN 01  ·  CERO ARTIFICIO</a:t>
+              <a:t>DIRECCIÓN DE ACTORES  ·  PROFE MIRANDA  ·  SESIÓN 01  ·  CERO ARTIFICIO</a:t>
             </a:r>
             <a:endParaRPr lang="en-US" sz="900" dirty="0"/>
           </a:p>
@@ -6881,7 +6920,7 @@
                 <a:ea typeface="Calibri" pitchFamily="34" charset="-122"/>
                 <a:cs typeface="Calibri" pitchFamily="34" charset="-120"/>
               </a:rPr>
-              <a:t>DIRECCIÓN DE ACTORES  ·  SESIÓN 01  ·  CERO ARTIFICIO</a:t>
+              <a:t>DIRECCIÓN DE ACTORES  ·  PROFE MIRANDA  ·  SESIÓN 01  ·  CERO ARTIFICIO</a:t>
             </a:r>
             <a:endParaRPr lang="en-US" sz="900" dirty="0"/>
           </a:p>
@@ -7613,7 +7652,7 @@
                 <a:ea typeface="Calibri" pitchFamily="34" charset="-122"/>
                 <a:cs typeface="Calibri" pitchFamily="34" charset="-120"/>
               </a:rPr>
-              <a:t>DIRECCIÓN DE ACTORES  ·  SESIÓN 01  ·  CERO ARTIFICIO</a:t>
+              <a:t>DIRECCIÓN DE ACTORES  ·  PROFE MIRANDA  ·  SESIÓN 01  ·  CERO ARTIFICIO</a:t>
             </a:r>
             <a:endParaRPr lang="en-US" sz="900" dirty="0"/>
           </a:p>
@@ -8451,7 +8490,7 @@
                 <a:ea typeface="Calibri" pitchFamily="34" charset="-122"/>
                 <a:cs typeface="Calibri" pitchFamily="34" charset="-120"/>
               </a:rPr>
-              <a:t>DIRECCIÓN DE ACTORES  ·  SESIÓN 01  ·  CERO ARTIFICIO</a:t>
+              <a:t>DIRECCIÓN DE ACTORES  ·  PROFE MIRANDA  ·  SESIÓN 01  ·  CERO ARTIFICIO</a:t>
             </a:r>
             <a:endParaRPr lang="en-US" sz="900" dirty="0"/>
           </a:p>

</xml_diff>